<commit_message>
perf: pin API to icn1 + add loading states + harden schema apply
- vercel.json: regions=["icn1"] to collocate API with Supabase ap-northeast-2
  (was iad1; cut cross-ocean RTT from ~150ms to ~2ms)
- Add loading.tsx for /games/[id] and /games/[id]/report so navigation
  shows instant skeleton + spinner instead of blocking on server render
- Terraform supabase module: replace psql provisioner with Python/psycopg
  via apply_schema.py; use Supabase session pooler (port 5432) for DDL
  so schema apply works without psql and IPv4-only hosts
- Drop unused postgresql provider from root; pass python_bin to module

Co-Authored-By: Claude Opus 4.7 <noreply@anthropic.com>
</commit_message>
<xml_diff>
--- a/docs/submission/submission.pptx
+++ b/docs/submission/submission.pptx
@@ -7205,7 +7205,7 @@
                 </a:solidFill>
                 <a:latin typeface="Consolas"/>
               </a:rPr>
-              <a:t>https://gca-web.vercel.app</a:t>
+              <a:t>https://gca-web-tan.vercel.app</a:t>
             </a:r>
           </a:p>
         </p:txBody>
@@ -7595,7 +7595,7 @@
                 </a:solidFill>
                 <a:latin typeface="Consolas"/>
               </a:rPr>
-              <a:t>https://github.com/ftkem2003/game-competitor-analysis-poc</a:t>
+              <a:t>https://github.com/hyukyyy/game-competitor-analysis-poc</a:t>
             </a:r>
           </a:p>
         </p:txBody>
@@ -8026,7 +8026,7 @@
                 </a:solidFill>
                 <a:latin typeface="Consolas"/>
               </a:rPr>
-              <a:t>gca-web.vercel.app /</a:t>
+              <a:t>gca-web-tan.vercel.app /</a:t>
             </a:r>
           </a:p>
         </p:txBody>
@@ -9315,7 +9315,7 @@
                 </a:solidFill>
                 <a:latin typeface="Consolas"/>
               </a:rPr>
-              <a:t>gca-web.vercel.app / games / [id]</a:t>
+              <a:t>gca-web-tan.vercel.app / games / [id]</a:t>
             </a:r>
           </a:p>
         </p:txBody>
@@ -10685,7 +10685,7 @@
                 </a:solidFill>
                 <a:latin typeface="Consolas"/>
               </a:rPr>
-              <a:t>gca-web.vercel.app / games / [id] / report</a:t>
+              <a:t>gca-web-tan.vercel.app / games / [id] / report</a:t>
             </a:r>
           </a:p>
         </p:txBody>
@@ -13671,7 +13671,7 @@
                 </a:solidFill>
                 <a:latin typeface="Consolas"/>
               </a:rPr>
-              <a:t>Source: https://github.com/ftkem2003/game-competitor-analysis-poc</a:t>
+              <a:t>Source: https://github.com/hyukyyy/game-competitor-analysis-poc</a:t>
             </a:r>
           </a:p>
         </p:txBody>

</xml_diff>